<commit_message>
Clarify modeled work loss and accessibility resources in submission deck
</commit_message>
<xml_diff>
--- a/submission/PathwayAI_Submission.pptx
+++ b/submission/PathwayAI_Submission.pptx
@@ -4886,7 +4886,7 @@
               </a:defRPr>
             </a:pPr>
             <a:r>
-              <a:t>Review and correct entries, then download the record for visits with different providers. The work-loss example stays separate from payments; caregiver time remains hours.</a:t>
+              <a:t>Work-loss value = entered days × chosen daily value. It is an estimate, not a bill. Keep it separate from payments; caregiver time stays in hours.</a:t>
             </a:r>
           </a:p>
         </p:txBody>
@@ -6709,7 +6709,7 @@
               <a:spcAft>
                 <a:spcPts val="1400"/>
               </a:spcAft>
-              <a:defRPr sz="2100" b="0">
+              <a:defRPr sz="1800" b="0">
                 <a:solidFill>
                   <a:srgbClr val="123149"/>
                 </a:solidFill>
@@ -6725,7 +6725,7 @@
               <a:spcAft>
                 <a:spcPts val="1400"/>
               </a:spcAft>
-              <a:defRPr sz="2100" b="0">
+              <a:defRPr sz="1800" b="0">
                 <a:solidFill>
                   <a:srgbClr val="123149"/>
                 </a:solidFill>
@@ -6741,7 +6741,7 @@
               <a:spcAft>
                 <a:spcPts val="1400"/>
               </a:spcAft>
-              <a:defRPr sz="2100" b="0">
+              <a:defRPr sz="1800" b="0">
                 <a:solidFill>
                   <a:srgbClr val="123149"/>
                 </a:solidFill>
@@ -6757,7 +6757,7 @@
               <a:spcAft>
                 <a:spcPts val="1400"/>
               </a:spcAft>
-              <a:defRPr sz="2100" b="0">
+              <a:defRPr sz="1800" b="0">
                 <a:solidFill>
                   <a:srgbClr val="123149"/>
                 </a:solidFill>
@@ -6766,6 +6766,22 @@
             </a:pPr>
             <a:r>
               <a:t>Support requests and county comparisons</a:t>
+            </a:r>
+          </a:p>
+          <a:p>
+            <a:pPr>
+              <a:spcAft>
+                <a:spcPts val="1400"/>
+              </a:spcAft>
+              <a:defRPr sz="1800" b="0">
+                <a:solidFill>
+                  <a:srgbClr val="123149"/>
+                </a:solidFill>
+                <a:latin typeface="Aptos"/>
+              </a:defRPr>
+            </a:pPr>
+            <a:r>
+              <a:t>Interpreter and accessibility resources</a:t>
             </a:r>
           </a:p>
         </p:txBody>

</xml_diff>